<commit_message>
Adjusted width of NFL team details textbox
</commit_message>
<xml_diff>
--- a/World.Wide.Sports.pptx
+++ b/World.Wide.Sports.pptx
@@ -15,6 +15,7 @@
     <p:sldId id="263" r:id="rId9"/>
     <p:sldId id="264" r:id="rId10"/>
     <p:sldId id="265" r:id="rId11"/>
+    <p:sldId id="266" r:id="rId12"/>
   </p:sldIdLst>
   <p:sldSz cx="12192000" cy="6858000"/>
   <p:notesSz cx="6858000" cy="9144000"/>
@@ -124,13 +125,100 @@
 <file path=ppt/revisionInfo.xml><?xml version="1.0" encoding="utf-8"?>
 <p1510:revInfo xmlns:a="http://schemas.openxmlformats.org/drawingml/2006/main" xmlns:r="http://schemas.openxmlformats.org/officeDocument/2006/relationships" xmlns:p1510="http://schemas.microsoft.com/office/powerpoint/2015/10/main">
   <p1510:revLst>
-    <p1510:client id="{99DFD6B3-DE16-49C8-BD2D-F5F4F1438CEF}" v="13" dt="2026-02-24T19:09:47.336"/>
+    <p1510:client id="{A56780C5-2625-4DB0-9174-CCE46758E175}" v="1" dt="2026-03-04T14:19:12.547"/>
   </p1510:revLst>
 </p1510:revInfo>
 </file>
 
 <file path=ppt/changesInfos/changesInfo1.xml><?xml version="1.0" encoding="utf-8"?>
 <pc:chgInfo xmlns:a="http://schemas.openxmlformats.org/drawingml/2006/main" xmlns:r="http://schemas.openxmlformats.org/officeDocument/2006/relationships" xmlns:ac="http://schemas.microsoft.com/office/drawing/2013/main/command" xmlns:pc="http://schemas.microsoft.com/office/powerpoint/2013/main/command">
+  <pc:docChgLst>
+    <pc:chgData name="Isaac billow" userId="80c6901a00b472fc" providerId="LiveId" clId="{0BE51010-B258-4B84-9833-D94740DDFD46}"/>
+    <pc:docChg chg="custSel addSld modSld">
+      <pc:chgData name="Isaac billow" userId="80c6901a00b472fc" providerId="LiveId" clId="{0BE51010-B258-4B84-9833-D94740DDFD46}" dt="2026-03-04T14:19:25.500" v="14" actId="14100"/>
+      <pc:docMkLst>
+        <pc:docMk/>
+      </pc:docMkLst>
+      <pc:sldChg chg="addSp delSp modSp mod">
+        <pc:chgData name="Isaac billow" userId="80c6901a00b472fc" providerId="LiveId" clId="{0BE51010-B258-4B84-9833-D94740DDFD46}" dt="2026-03-04T14:19:08.489" v="9" actId="1076"/>
+        <pc:sldMkLst>
+          <pc:docMk/>
+          <pc:sldMk cId="1165688574" sldId="265"/>
+        </pc:sldMkLst>
+        <pc:spChg chg="add del mod">
+          <ac:chgData name="Isaac billow" userId="80c6901a00b472fc" providerId="LiveId" clId="{0BE51010-B258-4B84-9833-D94740DDFD46}" dt="2026-03-04T14:18:51.886" v="7" actId="478"/>
+          <ac:spMkLst>
+            <pc:docMk/>
+            <pc:sldMk cId="1165688574" sldId="265"/>
+            <ac:spMk id="3" creationId="{1FA04E1A-715E-E77B-0325-795ADF0AA03D}"/>
+          </ac:spMkLst>
+        </pc:spChg>
+        <pc:picChg chg="del mod">
+          <ac:chgData name="Isaac billow" userId="80c6901a00b472fc" providerId="LiveId" clId="{0BE51010-B258-4B84-9833-D94740DDFD46}" dt="2026-03-04T14:18:25.327" v="2" actId="21"/>
+          <ac:picMkLst>
+            <pc:docMk/>
+            <pc:sldMk cId="1165688574" sldId="265"/>
+            <ac:picMk id="10" creationId="{66A2D6D3-282C-C719-1F5E-B4C9F11B74BF}"/>
+          </ac:picMkLst>
+        </pc:picChg>
+        <pc:picChg chg="mod">
+          <ac:chgData name="Isaac billow" userId="80c6901a00b472fc" providerId="LiveId" clId="{0BE51010-B258-4B84-9833-D94740DDFD46}" dt="2026-03-04T14:19:08.489" v="9" actId="1076"/>
+          <ac:picMkLst>
+            <pc:docMk/>
+            <pc:sldMk cId="1165688574" sldId="265"/>
+            <ac:picMk id="12" creationId="{E352EB6C-F989-C6BB-CB3F-B7E7DA349F3B}"/>
+          </ac:picMkLst>
+        </pc:picChg>
+      </pc:sldChg>
+      <pc:sldChg chg="addSp delSp modSp new mod">
+        <pc:chgData name="Isaac billow" userId="80c6901a00b472fc" providerId="LiveId" clId="{0BE51010-B258-4B84-9833-D94740DDFD46}" dt="2026-03-04T14:19:25.500" v="14" actId="14100"/>
+        <pc:sldMkLst>
+          <pc:docMk/>
+          <pc:sldMk cId="4170387049" sldId="266"/>
+        </pc:sldMkLst>
+        <pc:spChg chg="mod">
+          <ac:chgData name="Isaac billow" userId="80c6901a00b472fc" providerId="LiveId" clId="{0BE51010-B258-4B84-9833-D94740DDFD46}" dt="2026-03-04T14:19:25.500" v="14" actId="14100"/>
+          <ac:spMkLst>
+            <pc:docMk/>
+            <pc:sldMk cId="4170387049" sldId="266"/>
+            <ac:spMk id="2" creationId="{8364A0CE-85DF-B524-B0ED-CF680BD7F72B}"/>
+          </ac:spMkLst>
+        </pc:spChg>
+        <pc:spChg chg="del">
+          <ac:chgData name="Isaac billow" userId="80c6901a00b472fc" providerId="LiveId" clId="{0BE51010-B258-4B84-9833-D94740DDFD46}" dt="2026-03-04T14:18:38.061" v="3" actId="478"/>
+          <ac:spMkLst>
+            <pc:docMk/>
+            <pc:sldMk cId="4170387049" sldId="266"/>
+            <ac:spMk id="3" creationId="{790E68BD-B487-B6CC-5428-B45AD5C630D9}"/>
+          </ac:spMkLst>
+        </pc:spChg>
+        <pc:spChg chg="del">
+          <ac:chgData name="Isaac billow" userId="80c6901a00b472fc" providerId="LiveId" clId="{0BE51010-B258-4B84-9833-D94740DDFD46}" dt="2026-03-04T14:18:38.919" v="4" actId="478"/>
+          <ac:spMkLst>
+            <pc:docMk/>
+            <pc:sldMk cId="4170387049" sldId="266"/>
+            <ac:spMk id="4" creationId="{55E7D4FC-C1E1-E5FF-0C19-F2B759E5AF22}"/>
+          </ac:spMkLst>
+        </pc:spChg>
+        <pc:spChg chg="del">
+          <ac:chgData name="Isaac billow" userId="80c6901a00b472fc" providerId="LiveId" clId="{0BE51010-B258-4B84-9833-D94740DDFD46}" dt="2026-03-04T14:18:41.779" v="5" actId="478"/>
+          <ac:spMkLst>
+            <pc:docMk/>
+            <pc:sldMk cId="4170387049" sldId="266"/>
+            <ac:spMk id="5" creationId="{D810899C-5222-2DE4-F39B-6840325DC974}"/>
+          </ac:spMkLst>
+        </pc:spChg>
+        <pc:picChg chg="add mod">
+          <ac:chgData name="Isaac billow" userId="80c6901a00b472fc" providerId="LiveId" clId="{0BE51010-B258-4B84-9833-D94740DDFD46}" dt="2026-03-04T14:19:22.089" v="13" actId="14100"/>
+          <ac:picMkLst>
+            <pc:docMk/>
+            <pc:sldMk cId="4170387049" sldId="266"/>
+            <ac:picMk id="10" creationId="{66A2D6D3-282C-C719-1F5E-B4C9F11B74BF}"/>
+          </ac:picMkLst>
+        </pc:picChg>
+      </pc:sldChg>
+    </pc:docChg>
+  </pc:docChgLst>
   <pc:docChgLst>
     <pc:chgData name="Eric Maslyanchuk" userId="9dd3fc9552e8eb3b" providerId="LiveId" clId="{166E3E96-B408-4980-8D62-B34BA3B2756A}"/>
     <pc:docChg chg="undo custSel modSld sldOrd">
@@ -150,54 +238,6 @@
             <pc:docMk/>
             <pc:sldMk cId="268526464" sldId="257"/>
             <ac:spMk id="7" creationId="{290E6C86-D8D2-436C-C667-CD1FC5609910}"/>
-          </ac:spMkLst>
-        </pc:spChg>
-        <pc:spChg chg="add">
-          <ac:chgData name="Eric Maslyanchuk" userId="9dd3fc9552e8eb3b" providerId="LiveId" clId="{166E3E96-B408-4980-8D62-B34BA3B2756A}" dt="2026-02-24T19:06:46.398" v="0"/>
-          <ac:spMkLst>
-            <pc:docMk/>
-            <pc:sldMk cId="268526464" sldId="257"/>
-            <ac:spMk id="8" creationId="{363B4E5D-C936-9A8A-A542-791C9C2EAF47}"/>
-          </ac:spMkLst>
-        </pc:spChg>
-        <pc:spChg chg="add mod">
-          <ac:chgData name="Eric Maslyanchuk" userId="9dd3fc9552e8eb3b" providerId="LiveId" clId="{166E3E96-B408-4980-8D62-B34BA3B2756A}" dt="2026-02-24T19:07:45.860" v="8"/>
-          <ac:spMkLst>
-            <pc:docMk/>
-            <pc:sldMk cId="268526464" sldId="257"/>
-            <ac:spMk id="9" creationId="{8A927171-0DE8-46D6-FB15-F97F6260C366}"/>
-          </ac:spMkLst>
-        </pc:spChg>
-        <pc:spChg chg="add mod">
-          <ac:chgData name="Eric Maslyanchuk" userId="9dd3fc9552e8eb3b" providerId="LiveId" clId="{166E3E96-B408-4980-8D62-B34BA3B2756A}" dt="2026-02-24T19:07:45.692" v="7"/>
-          <ac:spMkLst>
-            <pc:docMk/>
-            <pc:sldMk cId="268526464" sldId="257"/>
-            <ac:spMk id="10" creationId="{3938B7DD-EF1E-E658-4A02-45E33D1E0C5E}"/>
-          </ac:spMkLst>
-        </pc:spChg>
-        <pc:spChg chg="add mod">
-          <ac:chgData name="Eric Maslyanchuk" userId="9dd3fc9552e8eb3b" providerId="LiveId" clId="{166E3E96-B408-4980-8D62-B34BA3B2756A}" dt="2026-02-24T19:07:45.499" v="6"/>
-          <ac:spMkLst>
-            <pc:docMk/>
-            <pc:sldMk cId="268526464" sldId="257"/>
-            <ac:spMk id="11" creationId="{852D6B7A-22F2-579F-31EF-1C4AED561D8B}"/>
-          </ac:spMkLst>
-        </pc:spChg>
-        <pc:spChg chg="add mod">
-          <ac:chgData name="Eric Maslyanchuk" userId="9dd3fc9552e8eb3b" providerId="LiveId" clId="{166E3E96-B408-4980-8D62-B34BA3B2756A}" dt="2026-02-24T19:07:45.206" v="5"/>
-          <ac:spMkLst>
-            <pc:docMk/>
-            <pc:sldMk cId="268526464" sldId="257"/>
-            <ac:spMk id="12" creationId="{39F88AD6-D177-A7E1-D3B5-F5072233B2CC}"/>
-          </ac:spMkLst>
-        </pc:spChg>
-        <pc:spChg chg="add">
-          <ac:chgData name="Eric Maslyanchuk" userId="9dd3fc9552e8eb3b" providerId="LiveId" clId="{166E3E96-B408-4980-8D62-B34BA3B2756A}" dt="2026-02-24T19:07:57.736" v="12"/>
-          <ac:spMkLst>
-            <pc:docMk/>
-            <pc:sldMk cId="268526464" sldId="257"/>
-            <ac:spMk id="13" creationId="{FF475E11-6890-148D-F238-FBB161E39455}"/>
           </ac:spMkLst>
         </pc:spChg>
       </pc:sldChg>
@@ -223,44 +263,12 @@
             <ac:spMk id="3" creationId="{847A5E32-3B36-44D1-0647-612F1A4577C3}"/>
           </ac:spMkLst>
         </pc:spChg>
-        <pc:spChg chg="add del">
-          <ac:chgData name="Eric Maslyanchuk" userId="9dd3fc9552e8eb3b" providerId="LiveId" clId="{166E3E96-B408-4980-8D62-B34BA3B2756A}" dt="2026-02-24T19:43:53.270" v="1030" actId="26606"/>
-          <ac:spMkLst>
-            <pc:docMk/>
-            <pc:sldMk cId="3891254845" sldId="259"/>
-            <ac:spMk id="20" creationId="{352BEC0E-22F8-46D0-9632-375DB541B06C}"/>
-          </ac:spMkLst>
-        </pc:spChg>
-        <pc:spChg chg="add del">
-          <ac:chgData name="Eric Maslyanchuk" userId="9dd3fc9552e8eb3b" providerId="LiveId" clId="{166E3E96-B408-4980-8D62-B34BA3B2756A}" dt="2026-02-24T19:43:53.270" v="1030" actId="26606"/>
-          <ac:spMkLst>
-            <pc:docMk/>
-            <pc:sldMk cId="3891254845" sldId="259"/>
-            <ac:spMk id="22" creationId="{3FCFB1DE-0B7E-48CC-BA90-B2AB0889F9D6}"/>
-          </ac:spMkLst>
-        </pc:spChg>
         <pc:picChg chg="mod">
           <ac:chgData name="Eric Maslyanchuk" userId="9dd3fc9552e8eb3b" providerId="LiveId" clId="{166E3E96-B408-4980-8D62-B34BA3B2756A}" dt="2026-02-24T19:44:34.068" v="1064" actId="1076"/>
           <ac:picMkLst>
             <pc:docMk/>
             <pc:sldMk cId="3891254845" sldId="259"/>
             <ac:picMk id="11" creationId="{E8F5B95A-4DEE-E298-06A0-5160766387F6}"/>
-          </ac:picMkLst>
-        </pc:picChg>
-        <pc:picChg chg="add del">
-          <ac:chgData name="Eric Maslyanchuk" userId="9dd3fc9552e8eb3b" providerId="LiveId" clId="{166E3E96-B408-4980-8D62-B34BA3B2756A}" dt="2026-02-24T19:43:31.952" v="1017" actId="478"/>
-          <ac:picMkLst>
-            <pc:docMk/>
-            <pc:sldMk cId="3891254845" sldId="259"/>
-            <ac:picMk id="13" creationId="{F14A4291-03A8-56E9-EED5-DDF176080069}"/>
-          </ac:picMkLst>
-        </pc:picChg>
-        <pc:picChg chg="add del mod">
-          <ac:chgData name="Eric Maslyanchuk" userId="9dd3fc9552e8eb3b" providerId="LiveId" clId="{166E3E96-B408-4980-8D62-B34BA3B2756A}" dt="2026-02-24T19:43:59.895" v="1032" actId="478"/>
-          <ac:picMkLst>
-            <pc:docMk/>
-            <pc:sldMk cId="3891254845" sldId="259"/>
-            <ac:picMk id="15" creationId="{99E05204-EC04-309D-9059-855042F21DD9}"/>
           </ac:picMkLst>
         </pc:picChg>
         <pc:picChg chg="add mod">
@@ -408,7 +416,7 @@
           <a:p>
             <a:fld id="{6EC0C652-4DE1-40EF-9D2C-9B2DD9303A0B}" type="datetimeFigureOut">
               <a:rPr lang="en-US" smtClean="0"/>
-              <a:t>3/2/2026</a:t>
+              <a:t>3/4/2026</a:t>
             </a:fld>
             <a:endParaRPr lang="en-US"/>
           </a:p>
@@ -578,7 +586,7 @@
           <a:p>
             <a:fld id="{6EC0C652-4DE1-40EF-9D2C-9B2DD9303A0B}" type="datetimeFigureOut">
               <a:rPr lang="en-US" smtClean="0"/>
-              <a:t>3/2/2026</a:t>
+              <a:t>3/4/2026</a:t>
             </a:fld>
             <a:endParaRPr lang="en-US"/>
           </a:p>
@@ -758,7 +766,7 @@
           <a:p>
             <a:fld id="{6EC0C652-4DE1-40EF-9D2C-9B2DD9303A0B}" type="datetimeFigureOut">
               <a:rPr lang="en-US" smtClean="0"/>
-              <a:t>3/2/2026</a:t>
+              <a:t>3/4/2026</a:t>
             </a:fld>
             <a:endParaRPr lang="en-US"/>
           </a:p>
@@ -928,7 +936,7 @@
           <a:p>
             <a:fld id="{6EC0C652-4DE1-40EF-9D2C-9B2DD9303A0B}" type="datetimeFigureOut">
               <a:rPr lang="en-US" smtClean="0"/>
-              <a:t>3/2/2026</a:t>
+              <a:t>3/4/2026</a:t>
             </a:fld>
             <a:endParaRPr lang="en-US"/>
           </a:p>
@@ -1174,7 +1182,7 @@
           <a:p>
             <a:fld id="{6EC0C652-4DE1-40EF-9D2C-9B2DD9303A0B}" type="datetimeFigureOut">
               <a:rPr lang="en-US" smtClean="0"/>
-              <a:t>3/2/2026</a:t>
+              <a:t>3/4/2026</a:t>
             </a:fld>
             <a:endParaRPr lang="en-US"/>
           </a:p>
@@ -1406,7 +1414,7 @@
           <a:p>
             <a:fld id="{6EC0C652-4DE1-40EF-9D2C-9B2DD9303A0B}" type="datetimeFigureOut">
               <a:rPr lang="en-US" smtClean="0"/>
-              <a:t>3/2/2026</a:t>
+              <a:t>3/4/2026</a:t>
             </a:fld>
             <a:endParaRPr lang="en-US"/>
           </a:p>
@@ -1773,7 +1781,7 @@
           <a:p>
             <a:fld id="{6EC0C652-4DE1-40EF-9D2C-9B2DD9303A0B}" type="datetimeFigureOut">
               <a:rPr lang="en-US" smtClean="0"/>
-              <a:t>3/2/2026</a:t>
+              <a:t>3/4/2026</a:t>
             </a:fld>
             <a:endParaRPr lang="en-US"/>
           </a:p>
@@ -1891,7 +1899,7 @@
           <a:p>
             <a:fld id="{6EC0C652-4DE1-40EF-9D2C-9B2DD9303A0B}" type="datetimeFigureOut">
               <a:rPr lang="en-US" smtClean="0"/>
-              <a:t>3/2/2026</a:t>
+              <a:t>3/4/2026</a:t>
             </a:fld>
             <a:endParaRPr lang="en-US"/>
           </a:p>
@@ -1986,7 +1994,7 @@
           <a:p>
             <a:fld id="{6EC0C652-4DE1-40EF-9D2C-9B2DD9303A0B}" type="datetimeFigureOut">
               <a:rPr lang="en-US" smtClean="0"/>
-              <a:t>3/2/2026</a:t>
+              <a:t>3/4/2026</a:t>
             </a:fld>
             <a:endParaRPr lang="en-US"/>
           </a:p>
@@ -2263,7 +2271,7 @@
           <a:p>
             <a:fld id="{6EC0C652-4DE1-40EF-9D2C-9B2DD9303A0B}" type="datetimeFigureOut">
               <a:rPr lang="en-US" smtClean="0"/>
-              <a:t>3/2/2026</a:t>
+              <a:t>3/4/2026</a:t>
             </a:fld>
             <a:endParaRPr lang="en-US"/>
           </a:p>
@@ -2520,7 +2528,7 @@
           <a:p>
             <a:fld id="{6EC0C652-4DE1-40EF-9D2C-9B2DD9303A0B}" type="datetimeFigureOut">
               <a:rPr lang="en-US" smtClean="0"/>
-              <a:t>3/2/2026</a:t>
+              <a:t>3/4/2026</a:t>
             </a:fld>
             <a:endParaRPr lang="en-US"/>
           </a:p>
@@ -2733,7 +2741,7 @@
           <a:p>
             <a:fld id="{6EC0C652-4DE1-40EF-9D2C-9B2DD9303A0B}" type="datetimeFigureOut">
               <a:rPr lang="en-US" smtClean="0"/>
-              <a:t>3/2/2026</a:t>
+              <a:t>3/4/2026</a:t>
             </a:fld>
             <a:endParaRPr lang="en-US"/>
           </a:p>
@@ -3226,38 +3234,6 @@
       </p:grpSpPr>
       <p:pic>
         <p:nvPicPr>
-          <p:cNvPr id="10" name="Content Placeholder 9">
-            <a:extLst>
-              <a:ext uri="{FF2B5EF4-FFF2-40B4-BE49-F238E27FC236}">
-                <a16:creationId xmlns:a16="http://schemas.microsoft.com/office/drawing/2014/main" id="{66A2D6D3-282C-C719-1F5E-B4C9F11B74BF}"/>
-              </a:ext>
-            </a:extLst>
-          </p:cNvPr>
-          <p:cNvPicPr>
-            <a:picLocks noGrp="1" noChangeAspect="1"/>
-          </p:cNvPicPr>
-          <p:nvPr>
-            <p:ph sz="half" idx="2"/>
-          </p:nvPr>
-        </p:nvPicPr>
-        <p:blipFill>
-          <a:blip r:embed="rId2"/>
-          <a:stretch>
-            <a:fillRect/>
-          </a:stretch>
-        </p:blipFill>
-        <p:spPr>
-          <a:xfrm>
-            <a:off x="839788" y="494331"/>
-            <a:ext cx="5157787" cy="5691539"/>
-          </a:xfrm>
-          <a:prstGeom prst="rect">
-            <a:avLst/>
-          </a:prstGeom>
-        </p:spPr>
-      </p:pic>
-      <p:pic>
-        <p:nvPicPr>
           <p:cNvPr id="12" name="Content Placeholder 11">
             <a:extLst>
               <a:ext uri="{FF2B5EF4-FFF2-40B4-BE49-F238E27FC236}">
@@ -3273,14 +3249,14 @@
           </p:nvPr>
         </p:nvPicPr>
         <p:blipFill>
-          <a:blip r:embed="rId3"/>
+          <a:blip r:embed="rId2"/>
           <a:stretch>
             <a:fillRect/>
           </a:stretch>
         </p:blipFill>
         <p:spPr>
           <a:xfrm>
-            <a:off x="6172200" y="494330"/>
+            <a:off x="3504406" y="583230"/>
             <a:ext cx="5183188" cy="5691539"/>
           </a:xfrm>
           <a:prstGeom prst="rect">
@@ -3292,6 +3268,123 @@
     <p:extLst>
       <p:ext uri="{BB962C8B-B14F-4D97-AF65-F5344CB8AC3E}">
         <p14:creationId xmlns:p14="http://schemas.microsoft.com/office/powerpoint/2010/main" val="1165688574"/>
+      </p:ext>
+    </p:extLst>
+  </p:cSld>
+  <p:clrMapOvr>
+    <a:masterClrMapping/>
+  </p:clrMapOvr>
+</p:sld>
+</file>
+
+<file path=ppt/slides/slide11.xml><?xml version="1.0" encoding="utf-8"?>
+<p:sld xmlns:a="http://schemas.openxmlformats.org/drawingml/2006/main" xmlns:r="http://schemas.openxmlformats.org/officeDocument/2006/relationships" xmlns:p="http://schemas.openxmlformats.org/presentationml/2006/main">
+  <p:cSld>
+    <p:spTree>
+      <p:nvGrpSpPr>
+        <p:cNvPr id="1" name=""/>
+        <p:cNvGrpSpPr/>
+        <p:nvPr/>
+      </p:nvGrpSpPr>
+      <p:grpSpPr>
+        <a:xfrm>
+          <a:off x="0" y="0"/>
+          <a:ext cx="0" cy="0"/>
+          <a:chOff x="0" y="0"/>
+          <a:chExt cx="0" cy="0"/>
+        </a:xfrm>
+      </p:grpSpPr>
+      <p:sp>
+        <p:nvSpPr>
+          <p:cNvPr id="2" name="Title 1">
+            <a:extLst>
+              <a:ext uri="{FF2B5EF4-FFF2-40B4-BE49-F238E27FC236}">
+                <a16:creationId xmlns:a16="http://schemas.microsoft.com/office/drawing/2014/main" id="{8364A0CE-85DF-B524-B0ED-CF680BD7F72B}"/>
+              </a:ext>
+            </a:extLst>
+          </p:cNvPr>
+          <p:cNvSpPr>
+            <a:spLocks noGrp="1"/>
+          </p:cNvSpPr>
+          <p:nvPr>
+            <p:ph type="title"/>
+          </p:nvPr>
+        </p:nvSpPr>
+        <p:spPr>
+          <a:xfrm>
+            <a:off x="839788" y="365125"/>
+            <a:ext cx="10515600" cy="923627"/>
+          </a:xfrm>
+        </p:spPr>
+        <p:txBody>
+          <a:bodyPr/>
+          <a:lstStyle/>
+          <a:p>
+            <a:endParaRPr lang="en-US" dirty="0"/>
+          </a:p>
+        </p:txBody>
+      </p:sp>
+      <p:sp>
+        <p:nvSpPr>
+          <p:cNvPr id="6" name="Content Placeholder 5">
+            <a:extLst>
+              <a:ext uri="{FF2B5EF4-FFF2-40B4-BE49-F238E27FC236}">
+                <a16:creationId xmlns:a16="http://schemas.microsoft.com/office/drawing/2014/main" id="{9EEBC398-A2AF-456A-7F9E-2960B034A6E2}"/>
+              </a:ext>
+            </a:extLst>
+          </p:cNvPr>
+          <p:cNvSpPr>
+            <a:spLocks noGrp="1"/>
+          </p:cNvSpPr>
+          <p:nvPr>
+            <p:ph sz="quarter" idx="4"/>
+          </p:nvPr>
+        </p:nvSpPr>
+        <p:spPr/>
+        <p:txBody>
+          <a:bodyPr/>
+          <a:lstStyle/>
+          <a:p>
+            <a:endParaRPr lang="en-US"/>
+          </a:p>
+        </p:txBody>
+      </p:sp>
+      <p:pic>
+        <p:nvPicPr>
+          <p:cNvPr id="10" name="Content Placeholder 9">
+            <a:extLst>
+              <a:ext uri="{FF2B5EF4-FFF2-40B4-BE49-F238E27FC236}">
+                <a16:creationId xmlns:a16="http://schemas.microsoft.com/office/drawing/2014/main" id="{66A2D6D3-282C-C719-1F5E-B4C9F11B74BF}"/>
+              </a:ext>
+            </a:extLst>
+          </p:cNvPr>
+          <p:cNvPicPr>
+            <a:picLocks noGrp="1" noChangeAspect="1"/>
+          </p:cNvPicPr>
+          <p:nvPr>
+            <p:ph sz="half" idx="2"/>
+          </p:nvPr>
+        </p:nvPicPr>
+        <p:blipFill>
+          <a:blip r:embed="rId2"/>
+          <a:stretch>
+            <a:fillRect/>
+          </a:stretch>
+        </p:blipFill>
+        <p:spPr>
+          <a:xfrm>
+            <a:off x="453162" y="1690688"/>
+            <a:ext cx="4351838" cy="4802187"/>
+          </a:xfrm>
+          <a:prstGeom prst="rect">
+            <a:avLst/>
+          </a:prstGeom>
+        </p:spPr>
+      </p:pic>
+    </p:spTree>
+    <p:extLst>
+      <p:ext uri="{BB962C8B-B14F-4D97-AF65-F5344CB8AC3E}">
+        <p14:creationId xmlns:p14="http://schemas.microsoft.com/office/powerpoint/2010/main" val="4170387049"/>
       </p:ext>
     </p:extLst>
   </p:cSld>

</xml_diff>